<commit_message>
Add 2-slide pitch deck (pptx + pdf)
Co-Authored-By: Claude Opus 4.7 (1M context) <noreply@anthropic.com>
</commit_message>
<xml_diff>
--- a/pitch.pptx
+++ b/pitch.pptx
@@ -7,10 +7,6 @@
   <p:sldIdLst>
     <p:sldId id="256" r:id="rId7"/>
     <p:sldId id="257" r:id="rId8"/>
-    <p:sldId id="258" r:id="rId9"/>
-    <p:sldId id="259" r:id="rId10"/>
-    <p:sldId id="260" r:id="rId11"/>
-    <p:sldId id="261" r:id="rId12"/>
   </p:sldIdLst>
   <p:sldSz cx="12191695" cy="6858000" type="screen4x3"/>
   <p:notesSz cx="6858000" cy="9144000"/>
@@ -3101,8 +3097,8 @@
         </p:nvSpPr>
         <p:spPr>
           <a:xfrm>
-            <a:off x="548640" y="2377440"/>
-            <a:ext cx="10972800" cy="1097280"/>
+            <a:off x="548640" y="365760"/>
+            <a:ext cx="10972800" cy="365760"/>
           </a:xfrm>
           <a:prstGeom prst="rect">
             <a:avLst/>
@@ -3117,13 +3113,13 @@
           <a:p>
             <a:pPr algn="l"/>
             <a:r>
-              <a:rPr sz="4800" b="1">
-                <a:solidFill>
-                  <a:srgbClr val="0E2A47"/>
+              <a:rPr sz="1200" b="1">
+                <a:solidFill>
+                  <a:srgbClr val="555555"/>
                 </a:solidFill>
                 <a:latin typeface="Helvetica"/>
               </a:rPr>
-              <a:t>ED Triage Support Assistant</a:t>
+              <a:t>01  ·  PROBLEM</a:t>
             </a:r>
           </a:p>
         </p:txBody>
@@ -3136,8 +3132,8 @@
         </p:nvSpPr>
         <p:spPr>
           <a:xfrm>
-            <a:off x="548640" y="3474720"/>
-            <a:ext cx="10972800" cy="548640"/>
+            <a:off x="548640" y="731520"/>
+            <a:ext cx="10972800" cy="914400"/>
           </a:xfrm>
           <a:prstGeom prst="rect">
             <a:avLst/>
@@ -3152,13 +3148,13 @@
           <a:p>
             <a:pPr algn="l"/>
             <a:r>
-              <a:rPr sz="2400" b="0">
-                <a:solidFill>
-                  <a:srgbClr val="555555"/>
+              <a:rPr sz="3200" b="1">
+                <a:solidFill>
+                  <a:srgbClr val="0E2A47"/>
                 </a:solidFill>
                 <a:latin typeface="Helvetica"/>
               </a:rPr>
-              <a:t>Decision support, not decision.</a:t>
+              <a:t>Triage today depends on which nurse is at the desk.</a:t>
             </a:r>
           </a:p>
         </p:txBody>
@@ -3171,8 +3167,8 @@
         </p:nvSpPr>
         <p:spPr>
           <a:xfrm>
-            <a:off x="548640" y="5120640"/>
-            <a:ext cx="10972800" cy="457200"/>
+            <a:off x="548640" y="2194560"/>
+            <a:ext cx="10972800" cy="3657600"/>
           </a:xfrm>
           <a:prstGeom prst="rect">
             <a:avLst/>
@@ -3185,15 +3181,102 @@
           </a:bodyPr>
           <a:lstStyle/>
           <a:p>
-            <a:pPr algn="l"/>
-            <a:r>
-              <a:rPr sz="1600" b="0">
-                <a:solidFill>
-                  <a:srgbClr val="555555"/>
+            <a:pPr>
+              <a:spcAft>
+                <a:spcPts val="800"/>
+              </a:spcAft>
+            </a:pPr>
+            <a:r>
+              <a:rPr sz="1800">
+                <a:solidFill>
+                  <a:srgbClr val="0E2A47"/>
                 </a:solidFill>
                 <a:latin typeface="Helvetica"/>
               </a:rPr>
-              <a:t>Cited rules. Logged overrides. No black box.</a:t>
+              <a:t>•  Same chest pain walks in twice → two different acuity scores, two different waits.</a:t>
+            </a:r>
+          </a:p>
+          <a:p>
+            <a:pPr>
+              <a:spcAft>
+                <a:spcPts val="800"/>
+              </a:spcAft>
+            </a:pPr>
+            <a:r>
+              <a:rPr sz="1800">
+                <a:solidFill>
+                  <a:srgbClr val="0E2A47"/>
+                </a:solidFill>
+                <a:latin typeface="Helvetica"/>
+              </a:rPr>
+              <a:t>•  No paper trail of why a tier was assigned.</a:t>
+            </a:r>
+          </a:p>
+          <a:p>
+            <a:pPr>
+              <a:spcAft>
+                <a:spcPts val="800"/>
+              </a:spcAft>
+            </a:pPr>
+            <a:r>
+              <a:rPr sz="1800">
+                <a:solidFill>
+                  <a:srgbClr val="0E2A47"/>
+                </a:solidFill>
+                <a:latin typeface="Helvetica"/>
+              </a:rPr>
+              <a:t>•  No flag when a clock is about to be missed (door-to-ECG, last monitored bed).</a:t>
+            </a:r>
+          </a:p>
+          <a:p>
+            <a:pPr>
+              <a:spcAft>
+                <a:spcPts val="800"/>
+              </a:spcAft>
+            </a:pPr>
+            <a:r>
+              <a:rPr sz="1800">
+                <a:solidFill>
+                  <a:srgbClr val="0E2A47"/>
+                </a:solidFill>
+                <a:latin typeface="Helvetica"/>
+              </a:rPr>
+              <a:t>•  When something goes wrong, the chart doesn't show what was considered or ruled out.</a:t>
+            </a:r>
+          </a:p>
+        </p:txBody>
+      </p:sp>
+      <p:sp>
+        <p:nvSpPr>
+          <p:cNvPr id="5" name="TextBox 4"/>
+          <p:cNvSpPr txBox="1"/>
+          <p:nvPr/>
+        </p:nvSpPr>
+        <p:spPr>
+          <a:xfrm>
+            <a:off x="548640" y="5669280"/>
+            <a:ext cx="10972800" cy="731520"/>
+          </a:xfrm>
+          <a:prstGeom prst="rect">
+            <a:avLst/>
+          </a:prstGeom>
+          <a:noFill/>
+        </p:spPr>
+        <p:txBody>
+          <a:bodyPr wrap="square">
+            <a:spAutoFit/>
+          </a:bodyPr>
+          <a:lstStyle/>
+          <a:p>
+            <a:pPr algn="l"/>
+            <a:r>
+              <a:rPr sz="1800" b="1">
+                <a:solidFill>
+                  <a:srgbClr val="C0392B"/>
+                </a:solidFill>
+                <a:latin typeface="Helvetica"/>
+              </a:rPr>
+              <a:t>The first 10 minutes of an ED visit are the most consequential — and the least documented.</a:t>
             </a:r>
           </a:p>
         </p:txBody>
@@ -3246,7 +3329,7 @@
                 </a:solidFill>
                 <a:latin typeface="Helvetica"/>
               </a:rPr>
-              <a:t>01  ·  PROBLEM</a:t>
+              <a:t>02  ·  PROTOTYPE</a:t>
             </a:r>
           </a:p>
         </p:txBody>
@@ -3281,216 +3364,6 @@
                 </a:solidFill>
                 <a:latin typeface="Helvetica"/>
               </a:rPr>
-              <a:t>Triage today depends on which nurse is at the desk.</a:t>
-            </a:r>
-          </a:p>
-        </p:txBody>
-      </p:sp>
-      <p:sp>
-        <p:nvSpPr>
-          <p:cNvPr id="4" name="TextBox 3"/>
-          <p:cNvSpPr txBox="1"/>
-          <p:nvPr/>
-        </p:nvSpPr>
-        <p:spPr>
-          <a:xfrm>
-            <a:off x="548640" y="2194560"/>
-            <a:ext cx="10972800" cy="3657600"/>
-          </a:xfrm>
-          <a:prstGeom prst="rect">
-            <a:avLst/>
-          </a:prstGeom>
-          <a:noFill/>
-        </p:spPr>
-        <p:txBody>
-          <a:bodyPr wrap="square">
-            <a:spAutoFit/>
-          </a:bodyPr>
-          <a:lstStyle/>
-          <a:p>
-            <a:pPr>
-              <a:spcAft>
-                <a:spcPts val="800"/>
-              </a:spcAft>
-            </a:pPr>
-            <a:r>
-              <a:rPr sz="1800">
-                <a:solidFill>
-                  <a:srgbClr val="0E2A47"/>
-                </a:solidFill>
-                <a:latin typeface="Helvetica"/>
-              </a:rPr>
-              <a:t>•  Same chest pain walks in twice → two different acuity scores, two different waits.</a:t>
-            </a:r>
-          </a:p>
-          <a:p>
-            <a:pPr>
-              <a:spcAft>
-                <a:spcPts val="800"/>
-              </a:spcAft>
-            </a:pPr>
-            <a:r>
-              <a:rPr sz="1800">
-                <a:solidFill>
-                  <a:srgbClr val="0E2A47"/>
-                </a:solidFill>
-                <a:latin typeface="Helvetica"/>
-              </a:rPr>
-              <a:t>•  No paper trail of why a tier was assigned.</a:t>
-            </a:r>
-          </a:p>
-          <a:p>
-            <a:pPr>
-              <a:spcAft>
-                <a:spcPts val="800"/>
-              </a:spcAft>
-            </a:pPr>
-            <a:r>
-              <a:rPr sz="1800">
-                <a:solidFill>
-                  <a:srgbClr val="0E2A47"/>
-                </a:solidFill>
-                <a:latin typeface="Helvetica"/>
-              </a:rPr>
-              <a:t>•  No flag when a clock is about to be missed (door-to-ECG, last monitored bed).</a:t>
-            </a:r>
-          </a:p>
-          <a:p>
-            <a:pPr>
-              <a:spcAft>
-                <a:spcPts val="800"/>
-              </a:spcAft>
-            </a:pPr>
-            <a:r>
-              <a:rPr sz="1800">
-                <a:solidFill>
-                  <a:srgbClr val="0E2A47"/>
-                </a:solidFill>
-                <a:latin typeface="Helvetica"/>
-              </a:rPr>
-              <a:t>•  When something goes wrong, the chart doesn't show what was considered or ruled out.</a:t>
-            </a:r>
-          </a:p>
-        </p:txBody>
-      </p:sp>
-      <p:sp>
-        <p:nvSpPr>
-          <p:cNvPr id="5" name="TextBox 4"/>
-          <p:cNvSpPr txBox="1"/>
-          <p:nvPr/>
-        </p:nvSpPr>
-        <p:spPr>
-          <a:xfrm>
-            <a:off x="548640" y="5669280"/>
-            <a:ext cx="10972800" cy="731520"/>
-          </a:xfrm>
-          <a:prstGeom prst="rect">
-            <a:avLst/>
-          </a:prstGeom>
-          <a:noFill/>
-        </p:spPr>
-        <p:txBody>
-          <a:bodyPr wrap="square">
-            <a:spAutoFit/>
-          </a:bodyPr>
-          <a:lstStyle/>
-          <a:p>
-            <a:pPr algn="l"/>
-            <a:r>
-              <a:rPr sz="1800" b="1">
-                <a:solidFill>
-                  <a:srgbClr val="C0392B"/>
-                </a:solidFill>
-                <a:latin typeface="Helvetica"/>
-              </a:rPr>
-              <a:t>The first 10 minutes of an ED visit are the most consequential — and the least documented.</a:t>
-            </a:r>
-          </a:p>
-        </p:txBody>
-      </p:sp>
-    </p:spTree>
-  </p:cSld>
-  <p:clrMapOvr>
-    <a:masterClrMapping/>
-  </p:clrMapOvr>
-</p:sld>
-</file>
-
-<file path=ppt/slides/slide3.xml><?xml version="1.0" encoding="utf-8"?>
-<p:sld xmlns:a="http://schemas.openxmlformats.org/drawingml/2006/main" xmlns:p="http://schemas.openxmlformats.org/presentationml/2006/main" xmlns:r="http://schemas.openxmlformats.org/officeDocument/2006/relationships">
-  <p:cSld>
-    <p:spTree>
-      <p:nvGrpSpPr>
-        <p:cNvPr id="1" name=""/>
-        <p:cNvGrpSpPr/>
-        <p:nvPr/>
-      </p:nvGrpSpPr>
-      <p:grpSpPr/>
-      <p:sp>
-        <p:nvSpPr>
-          <p:cNvPr id="2" name="TextBox 1"/>
-          <p:cNvSpPr txBox="1"/>
-          <p:nvPr/>
-        </p:nvSpPr>
-        <p:spPr>
-          <a:xfrm>
-            <a:off x="548640" y="365760"/>
-            <a:ext cx="10972800" cy="365760"/>
-          </a:xfrm>
-          <a:prstGeom prst="rect">
-            <a:avLst/>
-          </a:prstGeom>
-          <a:noFill/>
-        </p:spPr>
-        <p:txBody>
-          <a:bodyPr wrap="square">
-            <a:spAutoFit/>
-          </a:bodyPr>
-          <a:lstStyle/>
-          <a:p>
-            <a:pPr algn="l"/>
-            <a:r>
-              <a:rPr sz="1200" b="1">
-                <a:solidFill>
-                  <a:srgbClr val="555555"/>
-                </a:solidFill>
-                <a:latin typeface="Helvetica"/>
-              </a:rPr>
-              <a:t>02  ·  PROTOTYPE</a:t>
-            </a:r>
-          </a:p>
-        </p:txBody>
-      </p:sp>
-      <p:sp>
-        <p:nvSpPr>
-          <p:cNvPr id="3" name="TextBox 2"/>
-          <p:cNvSpPr txBox="1"/>
-          <p:nvPr/>
-        </p:nvSpPr>
-        <p:spPr>
-          <a:xfrm>
-            <a:off x="548640" y="731520"/>
-            <a:ext cx="10972800" cy="914400"/>
-          </a:xfrm>
-          <a:prstGeom prst="rect">
-            <a:avLst/>
-          </a:prstGeom>
-          <a:noFill/>
-        </p:spPr>
-        <p:txBody>
-          <a:bodyPr wrap="square">
-            <a:spAutoFit/>
-          </a:bodyPr>
-          <a:lstStyle/>
-          <a:p>
-            <a:pPr algn="l"/>
-            <a:r>
-              <a:rPr sz="3200" b="1">
-                <a:solidFill>
-                  <a:srgbClr val="0E2A47"/>
-                </a:solidFill>
-                <a:latin typeface="Helvetica"/>
-              </a:rPr>
               <a:t>Side-by-side input and output. Cited. Overridable.</a:t>
             </a:r>
           </a:p>
@@ -3819,1041 +3692,6 @@
                 <a:latin typeface="Helvetica"/>
               </a:rPr>
               <a:t>Below the columns: clinician confirms or overrides — every override logged with a reason.</a:t>
-            </a:r>
-          </a:p>
-        </p:txBody>
-      </p:sp>
-    </p:spTree>
-  </p:cSld>
-  <p:clrMapOvr>
-    <a:masterClrMapping/>
-  </p:clrMapOvr>
-</p:sld>
-</file>
-
-<file path=ppt/slides/slide4.xml><?xml version="1.0" encoding="utf-8"?>
-<p:sld xmlns:a="http://schemas.openxmlformats.org/drawingml/2006/main" xmlns:p="http://schemas.openxmlformats.org/presentationml/2006/main" xmlns:r="http://schemas.openxmlformats.org/officeDocument/2006/relationships">
-  <p:cSld>
-    <p:spTree>
-      <p:nvGrpSpPr>
-        <p:cNvPr id="1" name=""/>
-        <p:cNvGrpSpPr/>
-        <p:nvPr/>
-      </p:nvGrpSpPr>
-      <p:grpSpPr/>
-      <p:sp>
-        <p:nvSpPr>
-          <p:cNvPr id="2" name="TextBox 1"/>
-          <p:cNvSpPr txBox="1"/>
-          <p:nvPr/>
-        </p:nvSpPr>
-        <p:spPr>
-          <a:xfrm>
-            <a:off x="548640" y="365760"/>
-            <a:ext cx="10972800" cy="365760"/>
-          </a:xfrm>
-          <a:prstGeom prst="rect">
-            <a:avLst/>
-          </a:prstGeom>
-          <a:noFill/>
-        </p:spPr>
-        <p:txBody>
-          <a:bodyPr wrap="square">
-            <a:spAutoFit/>
-          </a:bodyPr>
-          <a:lstStyle/>
-          <a:p>
-            <a:pPr algn="l"/>
-            <a:r>
-              <a:rPr sz="1200" b="1">
-                <a:solidFill>
-                  <a:srgbClr val="555555"/>
-                </a:solidFill>
-                <a:latin typeface="Helvetica"/>
-              </a:rPr>
-              <a:t>03  ·  PROOF</a:t>
-            </a:r>
-          </a:p>
-        </p:txBody>
-      </p:sp>
-      <p:sp>
-        <p:nvSpPr>
-          <p:cNvPr id="3" name="TextBox 2"/>
-          <p:cNvSpPr txBox="1"/>
-          <p:nvPr/>
-        </p:nvSpPr>
-        <p:spPr>
-          <a:xfrm>
-            <a:off x="548640" y="731520"/>
-            <a:ext cx="10972800" cy="914400"/>
-          </a:xfrm>
-          <a:prstGeom prst="rect">
-            <a:avLst/>
-          </a:prstGeom>
-          <a:noFill/>
-        </p:spPr>
-        <p:txBody>
-          <a:bodyPr wrap="square">
-            <a:spAutoFit/>
-          </a:bodyPr>
-          <a:lstStyle/>
-          <a:p>
-            <a:pPr algn="l"/>
-            <a:r>
-              <a:rPr sz="3200" b="1">
-                <a:solidFill>
-                  <a:srgbClr val="0E2A47"/>
-                </a:solidFill>
-                <a:latin typeface="Helvetica"/>
-              </a:rPr>
-              <a:t>It doesn't blindly trust either signal.</a:t>
-            </a:r>
-          </a:p>
-        </p:txBody>
-      </p:sp>
-      <p:sp>
-        <p:nvSpPr>
-          <p:cNvPr id="4" name="TextBox 3"/>
-          <p:cNvSpPr txBox="1"/>
-          <p:nvPr/>
-        </p:nvSpPr>
-        <p:spPr>
-          <a:xfrm>
-            <a:off x="548640" y="1828800"/>
-            <a:ext cx="10972800" cy="457200"/>
-          </a:xfrm>
-          <a:prstGeom prst="rect">
-            <a:avLst/>
-          </a:prstGeom>
-          <a:noFill/>
-        </p:spPr>
-        <p:txBody>
-          <a:bodyPr wrap="square">
-            <a:spAutoFit/>
-          </a:bodyPr>
-          <a:lstStyle/>
-          <a:p>
-            <a:pPr algn="l"/>
-            <a:r>
-              <a:rPr sz="1800" b="0">
-                <a:solidFill>
-                  <a:srgbClr val="555555"/>
-                </a:solidFill>
-                <a:latin typeface="Helvetica"/>
-              </a:rPr>
-              <a:t>Two adversarial cases. Both correctly classified 🔴 NOW.</a:t>
-            </a:r>
-          </a:p>
-        </p:txBody>
-      </p:sp>
-      <p:graphicFrame>
-        <p:nvGraphicFramePr>
-          <p:cNvPr id="5" name="Table 4"/>
-          <p:cNvGraphicFramePr>
-            <a:graphicFrameLocks noGrp="1"/>
-          </p:cNvGraphicFramePr>
-          <p:nvPr/>
-        </p:nvGraphicFramePr>
-        <p:xfrm>
-          <a:off x="548640" y="2468880"/>
-          <a:ext cx="11064240" cy="2377440"/>
-        </p:xfrm>
-        <a:graphic>
-          <a:graphicData uri="http://schemas.openxmlformats.org/drawingml/2006/table">
-            <a:tbl>
-              <a:tblPr firstRow="1" bandRow="1">
-                <a:tableStyleId>{5C22544A-7EE6-4342-B048-85BDC9FD1C3A}</a:tableStyleId>
-              </a:tblPr>
-              <a:tblGrid>
-                <a:gridCol w="2011680"/>
-                <a:gridCol w="2286000"/>
-                <a:gridCol w="3200400"/>
-                <a:gridCol w="3566160"/>
-              </a:tblGrid>
-              <a:tr h="792480">
-                <a:tc>
-                  <a:txBody>
-                    <a:bodyPr/>
-                    <a:lstStyle/>
-                    <a:p>
-                      <a:r>
-                        <a:rPr b="1" sz="1300">
-                          <a:solidFill>
-                            <a:srgbClr val="0E2A47"/>
-                          </a:solidFill>
-                        </a:rPr>
-                        <a:t>Case</a:t>
-                      </a:r>
-                    </a:p>
-                  </a:txBody>
-                  <a:tcPr/>
-                </a:tc>
-                <a:tc>
-                  <a:txBody>
-                    <a:bodyPr/>
-                    <a:lstStyle/>
-                    <a:p>
-                      <a:r>
-                        <a:rPr b="1" sz="1300">
-                          <a:solidFill>
-                            <a:srgbClr val="0E2A47"/>
-                          </a:solidFill>
-                        </a:rPr>
-                        <a:t>Vitals</a:t>
-                      </a:r>
-                    </a:p>
-                  </a:txBody>
-                  <a:tcPr/>
-                </a:tc>
-                <a:tc>
-                  <a:txBody>
-                    <a:bodyPr/>
-                    <a:lstStyle/>
-                    <a:p>
-                      <a:r>
-                        <a:rPr b="1" sz="1300">
-                          <a:solidFill>
-                            <a:srgbClr val="0E2A47"/>
-                          </a:solidFill>
-                        </a:rPr>
-                        <a:t>Nurse note</a:t>
-                      </a:r>
-                    </a:p>
-                  </a:txBody>
-                  <a:tcPr/>
-                </a:tc>
-                <a:tc>
-                  <a:txBody>
-                    <a:bodyPr/>
-                    <a:lstStyle/>
-                    <a:p>
-                      <a:r>
-                        <a:rPr b="1" sz="1300">
-                          <a:solidFill>
-                            <a:srgbClr val="0E2A47"/>
-                          </a:solidFill>
-                        </a:rPr>
-                        <a:t>Verdict &amp; why</a:t>
-                      </a:r>
-                    </a:p>
-                  </a:txBody>
-                  <a:tcPr/>
-                </a:tc>
-              </a:tr>
-              <a:tr h="792480">
-                <a:tc>
-                  <a:txBody>
-                    <a:bodyPr/>
-                    <a:lstStyle/>
-                    <a:p>
-                      <a:r>
-                        <a:rPr sz="1100">
-                          <a:solidFill>
-                            <a:srgbClr val="0E2A47"/>
-                          </a:solidFill>
-                        </a:rPr>
-                        <a:t>ER-0052  Walter, 64M</a:t>
-                      </a:r>
-                    </a:p>
-                  </a:txBody>
-                  <a:tcPr/>
-                </a:tc>
-                <a:tc>
-                  <a:txBody>
-                    <a:bodyPr/>
-                    <a:lstStyle/>
-                    <a:p>
-                      <a:r>
-                        <a:rPr sz="1100">
-                          <a:solidFill>
-                            <a:srgbClr val="0E2A47"/>
-                          </a:solidFill>
-                        </a:rPr>
-                        <a:t>normal HR/BP/SpO2</a:t>
-                      </a:r>
-                    </a:p>
-                  </a:txBody>
-                  <a:tcPr/>
-                </a:tc>
-                <a:tc>
-                  <a:txBody>
-                    <a:bodyPr/>
-                    <a:lstStyle/>
-                    <a:p>
-                      <a:r>
-                        <a:rPr sz="1100">
-                          <a:solidFill>
-                            <a:srgbClr val="0E2A47"/>
-                          </a:solidFill>
-                        </a:rPr>
-                        <a:t>“ashen, drowsy, this is not him”</a:t>
-                      </a:r>
-                    </a:p>
-                  </a:txBody>
-                  <a:tcPr/>
-                </a:tc>
-                <a:tc>
-                  <a:txBody>
-                    <a:bodyPr/>
-                    <a:lstStyle/>
-                    <a:p>
-                      <a:r>
-                        <a:rPr sz="1100">
-                          <a:solidFill>
-                            <a:srgbClr val="0E2A47"/>
-                          </a:solidFill>
-                        </a:rPr>
-                        <a:t>🔴 NOW · medium</a:t>
-                      </a:r>
-                    </a:p>
-                    <a:p>
-                      <a:r>
-                        <a:rPr sz="1100">
-                          <a:solidFill>
-                            <a:srgbClr val="0E2A47"/>
-                          </a:solidFill>
-                        </a:rPr>
-                        <a:t>Altered mental status fires ESI-T2 regardless of vitals; amlodipine masks tachycardia</a:t>
-                      </a:r>
-                    </a:p>
-                  </a:txBody>
-                  <a:tcPr/>
-                </a:tc>
-              </a:tr>
-              <a:tr h="792480">
-                <a:tc>
-                  <a:txBody>
-                    <a:bodyPr/>
-                    <a:lstStyle/>
-                    <a:p>
-                      <a:r>
-                        <a:rPr sz="1100">
-                          <a:solidFill>
-                            <a:srgbClr val="0E2A47"/>
-                          </a:solidFill>
-                        </a:rPr>
-                        <a:t>ER-0053  Diana, 28F</a:t>
-                      </a:r>
-                    </a:p>
-                  </a:txBody>
-                  <a:tcPr/>
-                </a:tc>
-                <a:tc>
-                  <a:txBody>
-                    <a:bodyPr/>
-                    <a:lstStyle/>
-                    <a:p>
-                      <a:r>
-                        <a:rPr sz="1100">
-                          <a:solidFill>
-                            <a:srgbClr val="0E2A47"/>
-                          </a:solidFill>
-                        </a:rPr>
-                        <a:t>shock: HR 142 / SBP 88 / SpO2 91 / T 38.7</a:t>
-                      </a:r>
-                    </a:p>
-                  </a:txBody>
-                  <a:tcPr/>
-                </a:tc>
-                <a:tc>
-                  <a:txBody>
-                    <a:bodyPr/>
-                    <a:lstStyle/>
-                    <a:p>
-                      <a:r>
-                        <a:rPr sz="1100">
-                          <a:solidFill>
-                            <a:srgbClr val="0E2A47"/>
-                          </a:solidFill>
-                        </a:rPr>
-                        <a:t>“I feel fine, mom is overprotective”</a:t>
-                      </a:r>
-                    </a:p>
-                  </a:txBody>
-                  <a:tcPr/>
-                </a:tc>
-                <a:tc>
-                  <a:txBody>
-                    <a:bodyPr/>
-                    <a:lstStyle/>
-                    <a:p>
-                      <a:r>
-                        <a:rPr sz="1100">
-                          <a:solidFill>
-                            <a:srgbClr val="0E2A47"/>
-                          </a:solidFill>
-                        </a:rPr>
-                        <a:t>🔴 NOW · high</a:t>
-                      </a:r>
-                    </a:p>
-                    <a:p>
-                      <a:r>
-                        <a:rPr sz="1100">
-                          <a:solidFill>
-                            <a:srgbClr val="0E2A47"/>
-                          </a:solidFill>
-                        </a:rPr>
-                        <a:t>‘Appearance is not a vital sign’ — never downgrade shock vitals on self-report</a:t>
-                      </a:r>
-                    </a:p>
-                  </a:txBody>
-                  <a:tcPr/>
-                </a:tc>
-              </a:tr>
-            </a:tbl>
-          </a:graphicData>
-        </a:graphic>
-      </p:graphicFrame>
-      <p:sp>
-        <p:nvSpPr>
-          <p:cNvPr id="6" name="TextBox 5"/>
-          <p:cNvSpPr txBox="1"/>
-          <p:nvPr/>
-        </p:nvSpPr>
-        <p:spPr>
-          <a:xfrm>
-            <a:off x="548640" y="5120640"/>
-            <a:ext cx="10972800" cy="457200"/>
-          </a:xfrm>
-          <a:prstGeom prst="rect">
-            <a:avLst/>
-          </a:prstGeom>
-          <a:noFill/>
-        </p:spPr>
-        <p:txBody>
-          <a:bodyPr wrap="square">
-            <a:spAutoFit/>
-          </a:bodyPr>
-          <a:lstStyle/>
-          <a:p>
-            <a:pPr algn="l"/>
-            <a:r>
-              <a:rPr sz="1400" b="1">
-                <a:solidFill>
-                  <a:srgbClr val="555555"/>
-                </a:solidFill>
-                <a:latin typeface="Helvetica"/>
-              </a:rPr>
-              <a:t>By design:</a:t>
-            </a:r>
-          </a:p>
-        </p:txBody>
-      </p:sp>
-      <p:sp>
-        <p:nvSpPr>
-          <p:cNvPr id="7" name="TextBox 6"/>
-          <p:cNvSpPr txBox="1"/>
-          <p:nvPr/>
-        </p:nvSpPr>
-        <p:spPr>
-          <a:xfrm>
-            <a:off x="548640" y="5486400"/>
-            <a:ext cx="10972800" cy="1280160"/>
-          </a:xfrm>
-          <a:prstGeom prst="rect">
-            <a:avLst/>
-          </a:prstGeom>
-          <a:noFill/>
-        </p:spPr>
-        <p:txBody>
-          <a:bodyPr wrap="square">
-            <a:spAutoFit/>
-          </a:bodyPr>
-          <a:lstStyle/>
-          <a:p>
-            <a:pPr>
-              <a:spcAft>
-                <a:spcPts val="800"/>
-              </a:spcAft>
-            </a:pPr>
-            <a:r>
-              <a:rPr sz="1400">
-                <a:solidFill>
-                  <a:srgbClr val="0E2A47"/>
-                </a:solidFill>
-                <a:latin typeface="Helvetica"/>
-              </a:rPr>
-              <a:t>•  Any concerning signal — vitals OR notes OR history — can escalate the tier.</a:t>
-            </a:r>
-          </a:p>
-          <a:p>
-            <a:pPr>
-              <a:spcAft>
-                <a:spcPts val="800"/>
-              </a:spcAft>
-            </a:pPr>
-            <a:r>
-              <a:rPr sz="1400">
-                <a:solidFill>
-                  <a:srgbClr val="0E2A47"/>
-                </a:solidFill>
-                <a:latin typeface="Helvetica"/>
-              </a:rPr>
-              <a:t>•  Reassurance never down-triages. Conservative bias breaks ties, surfaced in the review note.</a:t>
-            </a:r>
-          </a:p>
-        </p:txBody>
-      </p:sp>
-    </p:spTree>
-  </p:cSld>
-  <p:clrMapOvr>
-    <a:masterClrMapping/>
-  </p:clrMapOvr>
-</p:sld>
-</file>
-
-<file path=ppt/slides/slide5.xml><?xml version="1.0" encoding="utf-8"?>
-<p:sld xmlns:a="http://schemas.openxmlformats.org/drawingml/2006/main" xmlns:p="http://schemas.openxmlformats.org/presentationml/2006/main" xmlns:r="http://schemas.openxmlformats.org/officeDocument/2006/relationships">
-  <p:cSld>
-    <p:spTree>
-      <p:nvGrpSpPr>
-        <p:cNvPr id="1" name=""/>
-        <p:cNvGrpSpPr/>
-        <p:nvPr/>
-      </p:nvGrpSpPr>
-      <p:grpSpPr/>
-      <p:sp>
-        <p:nvSpPr>
-          <p:cNvPr id="2" name="TextBox 1"/>
-          <p:cNvSpPr txBox="1"/>
-          <p:nvPr/>
-        </p:nvSpPr>
-        <p:spPr>
-          <a:xfrm>
-            <a:off x="548640" y="365760"/>
-            <a:ext cx="10972800" cy="365760"/>
-          </a:xfrm>
-          <a:prstGeom prst="rect">
-            <a:avLst/>
-          </a:prstGeom>
-          <a:noFill/>
-        </p:spPr>
-        <p:txBody>
-          <a:bodyPr wrap="square">
-            <a:spAutoFit/>
-          </a:bodyPr>
-          <a:lstStyle/>
-          <a:p>
-            <a:pPr algn="l"/>
-            <a:r>
-              <a:rPr sz="1200" b="1">
-                <a:solidFill>
-                  <a:srgbClr val="555555"/>
-                </a:solidFill>
-                <a:latin typeface="Helvetica"/>
-              </a:rPr>
-              <a:t>04  ·  ARCHITECTURE</a:t>
-            </a:r>
-          </a:p>
-        </p:txBody>
-      </p:sp>
-      <p:sp>
-        <p:nvSpPr>
-          <p:cNvPr id="3" name="TextBox 2"/>
-          <p:cNvSpPr txBox="1"/>
-          <p:nvPr/>
-        </p:nvSpPr>
-        <p:spPr>
-          <a:xfrm>
-            <a:off x="548640" y="731520"/>
-            <a:ext cx="10972800" cy="914400"/>
-          </a:xfrm>
-          <a:prstGeom prst="rect">
-            <a:avLst/>
-          </a:prstGeom>
-          <a:noFill/>
-        </p:spPr>
-        <p:txBody>
-          <a:bodyPr wrap="square">
-            <a:spAutoFit/>
-          </a:bodyPr>
-          <a:lstStyle/>
-          <a:p>
-            <a:pPr algn="l"/>
-            <a:r>
-              <a:rPr sz="3200" b="1">
-                <a:solidFill>
-                  <a:srgbClr val="0E2A47"/>
-                </a:solidFill>
-                <a:latin typeface="Helvetica"/>
-              </a:rPr>
-              <a:t>How it works.</a:t>
-            </a:r>
-          </a:p>
-        </p:txBody>
-      </p:sp>
-      <p:sp>
-        <p:nvSpPr>
-          <p:cNvPr id="4" name="TextBox 3"/>
-          <p:cNvSpPr txBox="1"/>
-          <p:nvPr/>
-        </p:nvSpPr>
-        <p:spPr>
-          <a:xfrm>
-            <a:off x="548640" y="1828800"/>
-            <a:ext cx="11247120" cy="3657600"/>
-          </a:xfrm>
-          <a:prstGeom prst="rect">
-            <a:avLst/>
-          </a:prstGeom>
-          <a:noFill/>
-        </p:spPr>
-        <p:txBody>
-          <a:bodyPr wrap="square">
-            <a:spAutoFit/>
-          </a:bodyPr>
-          <a:lstStyle/>
-          <a:p>
-            <a:pPr algn="l"/>
-            <a:r>
-              <a:rPr sz="1400" b="0">
-                <a:solidFill>
-                  <a:srgbClr val="0E2A47"/>
-                </a:solidFill>
-                <a:latin typeface="Menlo"/>
-              </a:rPr>
-              <a:t>inputs/                          app/                       outputs/</a:t>
-            </a:r>
-          </a:p>
-          <a:p>
-            <a:pPr algn="l"/>
-            <a:r>
-              <a:rPr sz="1400" b="0">
-                <a:solidFill>
-                  <a:srgbClr val="0E2A47"/>
-                </a:solidFill>
-                <a:latin typeface="Menlo"/>
-              </a:rPr>
-              <a:t>patients.json   ──┐</a:t>
-            </a:r>
-          </a:p>
-          <a:p>
-            <a:pPr algn="l"/>
-            <a:r>
-              <a:rPr sz="1400" b="0">
-                <a:solidFill>
-                  <a:srgbClr val="0E2A47"/>
-                </a:solidFill>
-                <a:latin typeface="Menlo"/>
-              </a:rPr>
-              <a:t>ed_state.json   ──┼──►  engine.py (Claude Opus 4.7) ──►  assessments/</a:t>
-            </a:r>
-          </a:p>
-          <a:p>
-            <a:pPr algn="l"/>
-            <a:r>
-              <a:rPr sz="1400" b="0">
-                <a:solidFill>
-                  <a:srgbClr val="0E2A47"/>
-                </a:solidFill>
-                <a:latin typeface="Menlo"/>
-              </a:rPr>
-              <a:t>guidelines.md   ──┘     · prompt-cached system + rules     {case_id}.json</a:t>
-            </a:r>
-          </a:p>
-          <a:p>
-            <a:pPr algn="l"/>
-            <a:r>
-              <a:rPr sz="1400" b="0">
-                <a:solidFill>
-                  <a:srgbClr val="0E2A47"/>
-                </a:solidFill>
-                <a:latin typeface="Menlo"/>
-              </a:rPr>
-              <a:t>                        · tool_use forces 6-panel JSON</a:t>
-            </a:r>
-          </a:p>
-          <a:p>
-            <a:pPr algn="l"/>
-            <a:r>
-              <a:rPr sz="1400" b="0">
-                <a:solidFill>
-                  <a:srgbClr val="0E2A47"/>
-                </a:solidFill>
-                <a:latin typeface="Menlo"/>
-              </a:rPr>
-              <a:t>                        · cites only real rule_ids</a:t>
-            </a:r>
-          </a:p>
-          <a:p>
-            <a:pPr algn="l"/>
-            <a:r>
-              <a:rPr sz="1400" b="0">
-                <a:solidFill>
-                  <a:srgbClr val="0E2A47"/>
-                </a:solidFill>
-                <a:latin typeface="Menlo"/>
-              </a:rPr>
-              <a:t/>
-            </a:r>
-          </a:p>
-          <a:p>
-            <a:pPr algn="l"/>
-            <a:r>
-              <a:rPr sz="1400" b="0">
-                <a:solidFill>
-                  <a:srgbClr val="0E2A47"/>
-                </a:solidFill>
-                <a:latin typeface="Menlo"/>
-              </a:rPr>
-              <a:t>                        streamlit_app.py  ◄──────────────────┘</a:t>
-            </a:r>
-          </a:p>
-          <a:p>
-            <a:pPr algn="l"/>
-            <a:r>
-              <a:rPr sz="1400" b="0">
-                <a:solidFill>
-                  <a:srgbClr val="0E2A47"/>
-                </a:solidFill>
-                <a:latin typeface="Menlo"/>
-              </a:rPr>
-              <a:t>                        · two-column input / output layout</a:t>
-            </a:r>
-          </a:p>
-          <a:p>
-            <a:pPr algn="l"/>
-            <a:r>
-              <a:rPr sz="1400" b="0">
-                <a:solidFill>
-                  <a:srgbClr val="0E2A47"/>
-                </a:solidFill>
-                <a:latin typeface="Menlo"/>
-              </a:rPr>
-              <a:t>                        · sidebar tier reads from assessment</a:t>
-            </a:r>
-          </a:p>
-          <a:p>
-            <a:pPr algn="l"/>
-            <a:r>
-              <a:rPr sz="1400" b="0">
-                <a:solidFill>
-                  <a:srgbClr val="0E2A47"/>
-                </a:solidFill>
-                <a:latin typeface="Menlo"/>
-              </a:rPr>
-              <a:t>                          (traceable to model decision, not pre-set)</a:t>
-            </a:r>
-          </a:p>
-        </p:txBody>
-      </p:sp>
-      <p:sp>
-        <p:nvSpPr>
-          <p:cNvPr id="5" name="TextBox 4"/>
-          <p:cNvSpPr txBox="1"/>
-          <p:nvPr/>
-        </p:nvSpPr>
-        <p:spPr>
-          <a:xfrm>
-            <a:off x="548640" y="5486400"/>
-            <a:ext cx="10972800" cy="1280160"/>
-          </a:xfrm>
-          <a:prstGeom prst="rect">
-            <a:avLst/>
-          </a:prstGeom>
-          <a:noFill/>
-        </p:spPr>
-        <p:txBody>
-          <a:bodyPr wrap="square">
-            <a:spAutoFit/>
-          </a:bodyPr>
-          <a:lstStyle/>
-          <a:p>
-            <a:pPr>
-              <a:spcAft>
-                <a:spcPts val="800"/>
-              </a:spcAft>
-            </a:pPr>
-            <a:r>
-              <a:rPr sz="1400">
-                <a:solidFill>
-                  <a:srgbClr val="0E2A47"/>
-                </a:solidFill>
-                <a:latin typeface="Helvetica"/>
-              </a:rPr>
-              <a:t>•  12 patient cases  ·  10 baseline + 2 adversarial</a:t>
-            </a:r>
-          </a:p>
-          <a:p>
-            <a:pPr>
-              <a:spcAft>
-                <a:spcPts val="800"/>
-              </a:spcAft>
-            </a:pPr>
-            <a:r>
-              <a:rPr sz="1400">
-                <a:solidFill>
-                  <a:srgbClr val="0E2A47"/>
-                </a:solidFill>
-                <a:latin typeface="Helvetica"/>
-              </a:rPr>
-              <a:t>•  18 named ESI v4 rule_ids the model is allowed to cite</a:t>
-            </a:r>
-          </a:p>
-          <a:p>
-            <a:pPr>
-              <a:spcAft>
-                <a:spcPts val="800"/>
-              </a:spcAft>
-            </a:pPr>
-            <a:r>
-              <a:rPr sz="1400">
-                <a:solidFill>
-                  <a:srgbClr val="0E2A47"/>
-                </a:solidFill>
-                <a:latin typeface="Helvetica"/>
-              </a:rPr>
-              <a:t>•  ~$0.02 per case  ·  8–15 sec latency</a:t>
-            </a:r>
-          </a:p>
-        </p:txBody>
-      </p:sp>
-    </p:spTree>
-  </p:cSld>
-  <p:clrMapOvr>
-    <a:masterClrMapping/>
-  </p:clrMapOvr>
-</p:sld>
-</file>
-
-<file path=ppt/slides/slide6.xml><?xml version="1.0" encoding="utf-8"?>
-<p:sld xmlns:a="http://schemas.openxmlformats.org/drawingml/2006/main" xmlns:p="http://schemas.openxmlformats.org/presentationml/2006/main" xmlns:r="http://schemas.openxmlformats.org/officeDocument/2006/relationships">
-  <p:cSld>
-    <p:spTree>
-      <p:nvGrpSpPr>
-        <p:cNvPr id="1" name=""/>
-        <p:cNvGrpSpPr/>
-        <p:nvPr/>
-      </p:nvGrpSpPr>
-      <p:grpSpPr/>
-      <p:sp>
-        <p:nvSpPr>
-          <p:cNvPr id="2" name="TextBox 1"/>
-          <p:cNvSpPr txBox="1"/>
-          <p:nvPr/>
-        </p:nvSpPr>
-        <p:spPr>
-          <a:xfrm>
-            <a:off x="548640" y="365760"/>
-            <a:ext cx="10972800" cy="365760"/>
-          </a:xfrm>
-          <a:prstGeom prst="rect">
-            <a:avLst/>
-          </a:prstGeom>
-          <a:noFill/>
-        </p:spPr>
-        <p:txBody>
-          <a:bodyPr wrap="square">
-            <a:spAutoFit/>
-          </a:bodyPr>
-          <a:lstStyle/>
-          <a:p>
-            <a:pPr algn="l"/>
-            <a:r>
-              <a:rPr sz="1200" b="1">
-                <a:solidFill>
-                  <a:srgbClr val="555555"/>
-                </a:solidFill>
-                <a:latin typeface="Helvetica"/>
-              </a:rPr>
-              <a:t>05  ·  THE ASK</a:t>
-            </a:r>
-          </a:p>
-        </p:txBody>
-      </p:sp>
-      <p:sp>
-        <p:nvSpPr>
-          <p:cNvPr id="3" name="TextBox 2"/>
-          <p:cNvSpPr txBox="1"/>
-          <p:nvPr/>
-        </p:nvSpPr>
-        <p:spPr>
-          <a:xfrm>
-            <a:off x="548640" y="731520"/>
-            <a:ext cx="10972800" cy="914400"/>
-          </a:xfrm>
-          <a:prstGeom prst="rect">
-            <a:avLst/>
-          </a:prstGeom>
-          <a:noFill/>
-        </p:spPr>
-        <p:txBody>
-          <a:bodyPr wrap="square">
-            <a:spAutoFit/>
-          </a:bodyPr>
-          <a:lstStyle/>
-          <a:p>
-            <a:pPr algn="l"/>
-            <a:r>
-              <a:rPr sz="3200" b="1">
-                <a:solidFill>
-                  <a:srgbClr val="0E2A47"/>
-                </a:solidFill>
-                <a:latin typeface="Helvetica"/>
-              </a:rPr>
-              <a:t>30-minute call. Pick one ED. Run shadow mode for 4 weeks.</a:t>
-            </a:r>
-          </a:p>
-        </p:txBody>
-      </p:sp>
-      <p:sp>
-        <p:nvSpPr>
-          <p:cNvPr id="4" name="TextBox 3"/>
-          <p:cNvSpPr txBox="1"/>
-          <p:nvPr/>
-        </p:nvSpPr>
-        <p:spPr>
-          <a:xfrm>
-            <a:off x="548640" y="2194560"/>
-            <a:ext cx="10972800" cy="3657600"/>
-          </a:xfrm>
-          <a:prstGeom prst="rect">
-            <a:avLst/>
-          </a:prstGeom>
-          <a:noFill/>
-        </p:spPr>
-        <p:txBody>
-          <a:bodyPr wrap="square">
-            <a:spAutoFit/>
-          </a:bodyPr>
-          <a:lstStyle/>
-          <a:p>
-            <a:pPr>
-              <a:spcAft>
-                <a:spcPts val="800"/>
-              </a:spcAft>
-            </a:pPr>
-            <a:r>
-              <a:rPr sz="1800">
-                <a:solidFill>
-                  <a:srgbClr val="0E2A47"/>
-                </a:solidFill>
-                <a:latin typeface="Helvetica"/>
-              </a:rPr>
-              <a:t>•  Charge nurse + IT lead, 30-minute call.</a:t>
-            </a:r>
-          </a:p>
-          <a:p>
-            <a:pPr>
-              <a:spcAft>
-                <a:spcPts val="800"/>
-              </a:spcAft>
-            </a:pPr>
-            <a:r>
-              <a:rPr sz="1800">
-                <a:solidFill>
-                  <a:srgbClr val="0E2A47"/>
-                </a:solidFill>
-                <a:latin typeface="Helvetica"/>
-              </a:rPr>
-              <a:t>•  One ED, four-week observation period.</a:t>
-            </a:r>
-          </a:p>
-          <a:p>
-            <a:pPr>
-              <a:spcAft>
-                <a:spcPts val="800"/>
-              </a:spcAft>
-            </a:pPr>
-            <a:r>
-              <a:rPr sz="1800">
-                <a:solidFill>
-                  <a:srgbClr val="0E2A47"/>
-                </a:solidFill>
-                <a:latin typeface="Helvetica"/>
-              </a:rPr>
-              <a:t>•  Shadow mode — assistant generates, nurse decides as today.</a:t>
-            </a:r>
-          </a:p>
-          <a:p>
-            <a:pPr>
-              <a:spcAft>
-                <a:spcPts val="800"/>
-              </a:spcAft>
-            </a:pPr>
-            <a:r>
-              <a:rPr sz="1800">
-                <a:solidFill>
-                  <a:srgbClr val="0E2A47"/>
-                </a:solidFill>
-                <a:latin typeface="Helvetica"/>
-              </a:rPr>
-              <a:t>•  We publish the disagreement rate against your senior clinicians' chart reviews.</a:t>
-            </a:r>
-          </a:p>
-          <a:p>
-            <a:pPr>
-              <a:spcAft>
-                <a:spcPts val="800"/>
-              </a:spcAft>
-            </a:pPr>
-            <a:r>
-              <a:rPr sz="1800">
-                <a:solidFill>
-                  <a:srgbClr val="0E2A47"/>
-                </a:solidFill>
-                <a:latin typeface="Helvetica"/>
-              </a:rPr>
-              <a:t>•  You decide whether to keep it.</a:t>
-            </a:r>
-          </a:p>
-        </p:txBody>
-      </p:sp>
-      <p:sp>
-        <p:nvSpPr>
-          <p:cNvPr id="5" name="TextBox 4"/>
-          <p:cNvSpPr txBox="1"/>
-          <p:nvPr/>
-        </p:nvSpPr>
-        <p:spPr>
-          <a:xfrm>
-            <a:off x="548640" y="5486400"/>
-            <a:ext cx="10972800" cy="914400"/>
-          </a:xfrm>
-          <a:prstGeom prst="rect">
-            <a:avLst/>
-          </a:prstGeom>
-          <a:noFill/>
-        </p:spPr>
-        <p:txBody>
-          <a:bodyPr wrap="square">
-            <a:spAutoFit/>
-          </a:bodyPr>
-          <a:lstStyle/>
-          <a:p>
-            <a:pPr algn="l"/>
-            <a:r>
-              <a:rPr sz="1800" b="1">
-                <a:solidFill>
-                  <a:srgbClr val="0E2A47"/>
-                </a:solidFill>
-                <a:latin typeface="Helvetica"/>
-              </a:rPr>
-              <a:t>Decision support, not decision.</a:t>
-            </a:r>
-          </a:p>
-          <a:p>
-            <a:pPr algn="l"/>
-            <a:r>
-              <a:rPr sz="1800" b="1">
-                <a:solidFill>
-                  <a:srgbClr val="0E2A47"/>
-                </a:solidFill>
-                <a:latin typeface="Helvetica"/>
-              </a:rPr>
-              <a:t>Cited rules, not opinions.</a:t>
-            </a:r>
-          </a:p>
-          <a:p>
-            <a:pPr algn="l"/>
-            <a:r>
-              <a:rPr sz="1800" b="1">
-                <a:solidFill>
-                  <a:srgbClr val="0E2A47"/>
-                </a:solidFill>
-                <a:latin typeface="Helvetica"/>
-              </a:rPr>
-              <a:t>Logged overrides, not a black box.</a:t>
             </a:r>
           </a:p>
         </p:txBody>

</xml_diff>